<commit_message>
Cdiscount Voyages: revue client sur modèle d'août
Co-Authored-By: Claude Opus 5.5 <noreply@anthropic.com>
Claude-Session: https://claude.ai/code/session_01BmxtdWjbeRUyPx9e1qVLbT
</commit_message>
<xml_diff>
--- a/rapports/septembre/Cdiscount_Voyages_Sejours_sept2026.pptx
+++ b/rapports/septembre/Cdiscount_Voyages_Sejours_sept2026.pptx
@@ -5283,16 +5283,16 @@
               </a:spcAft>
             </a:pPr>
             <a:r>
+              <a:rPr sz="2000" b="1" i="0">
+                <a:solidFill>
+                  <a:srgbClr val="EE6A2C"/>
+                </a:solidFill>
+                <a:latin typeface="Arial"/>
+              </a:rPr>
+              <a:t>hôtel</a:t>
+            </a:r>
+            <a:r>
               <a:rPr sz="1800" b="1" i="0">
-                <a:solidFill>
-                  <a:srgbClr val="EE6A2C"/>
-                </a:solidFill>
-                <a:latin typeface="Arial"/>
-              </a:rPr>
-              <a:t>départ en vacances</a:t>
-            </a:r>
-            <a:r>
-              <a:rPr sz="1600" b="1" i="0">
                 <a:solidFill>
                   <a:srgbClr val="111111"/>
                 </a:solidFill>
@@ -5314,7 +5314,7 @@
                 </a:solidFill>
                 <a:latin typeface="Arial"/>
               </a:rPr>
-              <a:t>Airbnb</a:t>
+              <a:t>Canaries</a:t>
             </a:r>
             <a:r>
               <a:rPr sz="1400" b="1" i="0">
@@ -5323,7 +5323,7 @@
                 </a:solidFill>
                 <a:latin typeface="Arial"/>
               </a:rPr>
-              <a:t>   Booking</a:t>
+              <a:t>   Baléares</a:t>
             </a:r>
           </a:p>
           <a:p>
@@ -5339,7 +5339,7 @@
                 </a:solidFill>
                 <a:latin typeface="Arial"/>
               </a:rPr>
-              <a:t>Club Med</a:t>
+              <a:t>tout compris</a:t>
             </a:r>
             <a:r>
               <a:rPr sz="1200" b="0" i="0">
@@ -5348,7 +5348,16 @@
                 </a:solidFill>
                 <a:latin typeface="Arial"/>
               </a:rPr>
-              <a:t>   Pierre &amp; Vacances</a:t>
+              <a:t>   club</a:t>
+            </a:r>
+            <a:r>
+              <a:rPr sz="1200" b="1" i="0">
+                <a:solidFill>
+                  <a:srgbClr val="111111"/>
+                </a:solidFill>
+                <a:latin typeface="Arial"/>
+              </a:rPr>
+              <a:t>   soleil</a:t>
             </a:r>
           </a:p>
           <a:p>
@@ -5364,7 +5373,7 @@
                 </a:solidFill>
                 <a:latin typeface="Arial"/>
               </a:rPr>
-              <a:t>billets d'avion</a:t>
+              <a:t>Fuerteventura</a:t>
             </a:r>
             <a:r>
               <a:rPr sz="1100" b="1" i="0">
@@ -5373,7 +5382,16 @@
                 </a:solidFill>
                 <a:latin typeface="Arial"/>
               </a:rPr>
-              <a:t>   Transavia</a:t>
+              <a:t>   Majorque</a:t>
+            </a:r>
+            <a:r>
+              <a:rPr sz="1100" b="0" i="0">
+                <a:solidFill>
+                  <a:srgbClr val="555B66"/>
+                </a:solidFill>
+                <a:latin typeface="Arial"/>
+              </a:rPr>
+              <a:t>   Grèce</a:t>
             </a:r>
           </a:p>
           <a:p>
@@ -5389,7 +5407,7 @@
                 </a:solidFill>
                 <a:latin typeface="Arial"/>
               </a:rPr>
-              <a:t>valise cabine</a:t>
+              <a:t>paiement en 4 fois</a:t>
             </a:r>
             <a:r>
               <a:rPr sz="1100" b="0" i="0">
@@ -5398,7 +5416,16 @@
                 </a:solidFill>
                 <a:latin typeface="Arial"/>
               </a:rPr>
-              <a:t>   trousse de toilette</a:t>
+              <a:t>   plage</a:t>
+            </a:r>
+            <a:r>
+              <a:rPr sz="1100" b="1" i="0">
+                <a:solidFill>
+                  <a:srgbClr val="EE6A2C"/>
+                </a:solidFill>
+                <a:latin typeface="Arial"/>
+              </a:rPr>
+              <a:t>   Dubaï</a:t>
             </a:r>
           </a:p>
           <a:p>
@@ -5414,7 +5441,7 @@
                 </a:solidFill>
                 <a:latin typeface="Arial"/>
               </a:rPr>
-              <a:t>Center Parcs</a:t>
+              <a:t>Tunisie</a:t>
             </a:r>
             <a:r>
               <a:rPr sz="1100" b="0" i="0">
@@ -5423,16 +5450,7 @@
                 </a:solidFill>
                 <a:latin typeface="Arial"/>
               </a:rPr>
-              <a:t>   TUI</a:t>
-            </a:r>
-            <a:r>
-              <a:rPr sz="1100" b="0" i="0">
-                <a:solidFill>
-                  <a:srgbClr val="EE6A2C"/>
-                </a:solidFill>
-                <a:latin typeface="Arial"/>
-              </a:rPr>
-              <a:t>   Lastminute</a:t>
+              <a:t>   petit prix</a:t>
             </a:r>
           </a:p>
         </p:txBody>
@@ -5616,7 +5634,7 @@
                 </a:solidFill>
                 <a:latin typeface="Arial"/>
               </a:rPr>
-              <a:t>Comment choisir un sac cabine conforme aux dimensions des compagnies ?</a:t>
+              <a:t>Où partir au soleil en octobre ?</a:t>
             </a:r>
           </a:p>
         </p:txBody>
@@ -5730,7 +5748,7 @@
                 </a:solidFill>
                 <a:latin typeface="Arial"/>
               </a:rPr>
-              <a:t>Comment organiser une trousse de toilette conforme aux règles de sécurité ?</a:t>
+              <a:t>Quel séjour tout compris pour une famille ?</a:t>
             </a:r>
           </a:p>
         </p:txBody>
@@ -5844,14 +5862,128 @@
                 </a:solidFill>
                 <a:latin typeface="Arial"/>
               </a:rPr>
-              <a:t>Quelles offres ou prix pour une pochette Faraday ?</a:t>
-            </a:r>
-          </a:p>
-        </p:txBody>
-      </p:sp>
-      <p:sp>
-        <p:nvSpPr>
-          <p:cNvPr id="71" name="TextBox 70"/>
+              <a:t>Peut-on payer un voyage en quatre fois ?</a:t>
+            </a:r>
+          </a:p>
+        </p:txBody>
+      </p:sp>
+      <p:sp>
+        <p:nvSpPr>
+          <p:cNvPr id="71" name="Rectangle 70"/>
+          <p:cNvSpPr/>
+          <p:nvPr/>
+        </p:nvSpPr>
+        <p:spPr>
+          <a:xfrm>
+            <a:off x="4437888" y="5364480"/>
+            <a:ext cx="2913888" cy="304800"/>
+          </a:xfrm>
+          <a:prstGeom prst="rect">
+            <a:avLst/>
+          </a:prstGeom>
+          <a:solidFill>
+            <a:srgbClr val="F1EFEA"/>
+          </a:solidFill>
+          <a:ln>
+            <a:noFill/>
+          </a:ln>
+          <a:effectLst/>
+        </p:spPr>
+        <p:style>
+          <a:lnRef idx="1">
+            <a:schemeClr val="accent1"/>
+          </a:lnRef>
+          <a:fillRef idx="3">
+            <a:schemeClr val="accent1"/>
+          </a:fillRef>
+          <a:effectRef idx="2">
+            <a:schemeClr val="accent1"/>
+          </a:effectRef>
+          <a:fontRef idx="minor">
+            <a:schemeClr val="lt1"/>
+          </a:fontRef>
+        </p:style>
+        <p:txBody>
+          <a:bodyPr rtlCol="0" anchor="ctr"/>
+          <a:lstStyle/>
+          <a:p>
+            <a:pPr algn="ctr"/>
+          </a:p>
+        </p:txBody>
+      </p:sp>
+      <p:sp>
+        <p:nvSpPr>
+          <p:cNvPr id="72" name="TextBox 71"/>
+          <p:cNvSpPr txBox="1"/>
+          <p:nvPr/>
+        </p:nvSpPr>
+        <p:spPr>
+          <a:xfrm>
+            <a:off x="4559808" y="5364480"/>
+            <a:ext cx="182880" cy="304800"/>
+          </a:xfrm>
+          <a:prstGeom prst="rect">
+            <a:avLst/>
+          </a:prstGeom>
+          <a:noFill/>
+        </p:spPr>
+        <p:txBody>
+          <a:bodyPr wrap="square" anchor="ctr" lIns="0" rIns="0" tIns="0" bIns="0">
+            <a:spAutoFit/>
+          </a:bodyPr>
+          <a:lstStyle/>
+          <a:p>
+            <a:pPr algn="l"/>
+            <a:r>
+              <a:rPr sz="900" b="0" i="0">
+                <a:solidFill>
+                  <a:srgbClr val="555B66"/>
+                </a:solidFill>
+                <a:latin typeface="Arial"/>
+              </a:rPr>
+              <a:t>🔍</a:t>
+            </a:r>
+          </a:p>
+        </p:txBody>
+      </p:sp>
+      <p:sp>
+        <p:nvSpPr>
+          <p:cNvPr id="73" name="TextBox 72"/>
+          <p:cNvSpPr txBox="1"/>
+          <p:nvPr/>
+        </p:nvSpPr>
+        <p:spPr>
+          <a:xfrm>
+            <a:off x="4791456" y="5364480"/>
+            <a:ext cx="2499360" cy="304800"/>
+          </a:xfrm>
+          <a:prstGeom prst="rect">
+            <a:avLst/>
+          </a:prstGeom>
+          <a:noFill/>
+        </p:spPr>
+        <p:txBody>
+          <a:bodyPr wrap="square" anchor="ctr" lIns="0" rIns="0" tIns="0" bIns="0">
+            <a:spAutoFit/>
+          </a:bodyPr>
+          <a:lstStyle/>
+          <a:p>
+            <a:pPr algn="l"/>
+            <a:r>
+              <a:rPr sz="900" b="0" i="0">
+                <a:solidFill>
+                  <a:srgbClr val="111111"/>
+                </a:solidFill>
+                <a:latin typeface="Arial"/>
+              </a:rPr>
+              <a:t>Quel hôtel choisir aux Canaries pour la Toussaint ?</a:t>
+            </a:r>
+          </a:p>
+        </p:txBody>
+      </p:sp>
+      <p:sp>
+        <p:nvSpPr>
+          <p:cNvPr id="74" name="TextBox 73"/>
           <p:cNvSpPr txBox="1"/>
           <p:nvPr/>
         </p:nvSpPr>
@@ -5886,7 +6018,7 @@
       </p:sp>
       <p:sp>
         <p:nvSpPr>
-          <p:cNvPr id="72" name="TextBox 71"/>
+          <p:cNvPr id="75" name="TextBox 74"/>
           <p:cNvSpPr txBox="1"/>
           <p:nvPr/>
         </p:nvSpPr>
@@ -5921,7 +6053,7 @@
       </p:sp>
       <p:sp>
         <p:nvSpPr>
-          <p:cNvPr id="73" name="TextBox 72"/>
+          <p:cNvPr id="76" name="TextBox 75"/>
           <p:cNvSpPr txBox="1"/>
           <p:nvPr/>
         </p:nvSpPr>
@@ -5956,7 +6088,7 @@
       </p:sp>
       <p:sp>
         <p:nvSpPr>
-          <p:cNvPr id="74" name="Rectangle 73"/>
+          <p:cNvPr id="77" name="Rectangle 76"/>
           <p:cNvSpPr/>
           <p:nvPr/>
         </p:nvSpPr>
@@ -6000,7 +6132,7 @@
       </p:sp>
       <p:sp>
         <p:nvSpPr>
-          <p:cNvPr id="75" name="TextBox 74"/>
+          <p:cNvPr id="78" name="TextBox 77"/>
           <p:cNvSpPr txBox="1"/>
           <p:nvPr/>
         </p:nvSpPr>
@@ -6035,7 +6167,7 @@
       </p:sp>
       <p:sp>
         <p:nvSpPr>
-          <p:cNvPr id="76" name="Rectangle 75"/>
+          <p:cNvPr id="79" name="Rectangle 78"/>
           <p:cNvSpPr/>
           <p:nvPr/>
         </p:nvSpPr>
@@ -6079,7 +6211,7 @@
       </p:sp>
       <p:sp>
         <p:nvSpPr>
-          <p:cNvPr id="77" name="TextBox 76"/>
+          <p:cNvPr id="80" name="TextBox 79"/>
           <p:cNvSpPr txBox="1"/>
           <p:nvPr/>
         </p:nvSpPr>
@@ -6114,7 +6246,7 @@
       </p:sp>
       <p:sp>
         <p:nvSpPr>
-          <p:cNvPr id="78" name="Rectangle 77"/>
+          <p:cNvPr id="81" name="Rectangle 80"/>
           <p:cNvSpPr/>
           <p:nvPr/>
         </p:nvSpPr>
@@ -6158,7 +6290,7 @@
       </p:sp>
       <p:sp>
         <p:nvSpPr>
-          <p:cNvPr id="79" name="TextBox 78"/>
+          <p:cNvPr id="82" name="TextBox 81"/>
           <p:cNvSpPr txBox="1"/>
           <p:nvPr/>
         </p:nvSpPr>
@@ -6193,7 +6325,7 @@
       </p:sp>
       <p:sp>
         <p:nvSpPr>
-          <p:cNvPr id="80" name="Rectangle 79"/>
+          <p:cNvPr id="83" name="Rectangle 82"/>
           <p:cNvSpPr/>
           <p:nvPr/>
         </p:nvSpPr>
@@ -6237,7 +6369,7 @@
       </p:sp>
       <p:sp>
         <p:nvSpPr>
-          <p:cNvPr id="81" name="TextBox 80"/>
+          <p:cNvPr id="84" name="TextBox 83"/>
           <p:cNvSpPr txBox="1"/>
           <p:nvPr/>
         </p:nvSpPr>
@@ -6272,7 +6404,7 @@
       </p:sp>
       <p:sp>
         <p:nvSpPr>
-          <p:cNvPr id="82" name="Rectangle 81"/>
+          <p:cNvPr id="85" name="Rectangle 84"/>
           <p:cNvSpPr/>
           <p:nvPr/>
         </p:nvSpPr>
@@ -6316,7 +6448,7 @@
       </p:sp>
       <p:sp>
         <p:nvSpPr>
-          <p:cNvPr id="83" name="TextBox 82"/>
+          <p:cNvPr id="86" name="TextBox 85"/>
           <p:cNvSpPr txBox="1"/>
           <p:nvPr/>
         </p:nvSpPr>
@@ -6351,7 +6483,7 @@
       </p:sp>
       <p:sp>
         <p:nvSpPr>
-          <p:cNvPr id="84" name="Rectangle 83"/>
+          <p:cNvPr id="87" name="Rectangle 86"/>
           <p:cNvSpPr/>
           <p:nvPr/>
         </p:nvSpPr>
@@ -6395,7 +6527,7 @@
       </p:sp>
       <p:sp>
         <p:nvSpPr>
-          <p:cNvPr id="85" name="TextBox 84"/>
+          <p:cNvPr id="88" name="TextBox 87"/>
           <p:cNvSpPr txBox="1"/>
           <p:nvPr/>
         </p:nvSpPr>
@@ -6430,7 +6562,7 @@
       </p:sp>
       <p:sp>
         <p:nvSpPr>
-          <p:cNvPr id="86" name="Rectangle 85"/>
+          <p:cNvPr id="89" name="Rectangle 88"/>
           <p:cNvSpPr/>
           <p:nvPr/>
         </p:nvSpPr>
@@ -6474,7 +6606,7 @@
       </p:sp>
       <p:sp>
         <p:nvSpPr>
-          <p:cNvPr id="87" name="TextBox 86"/>
+          <p:cNvPr id="90" name="TextBox 89"/>
           <p:cNvSpPr txBox="1"/>
           <p:nvPr/>
         </p:nvSpPr>
@@ -6509,7 +6641,7 @@
       </p:sp>
       <p:sp>
         <p:nvSpPr>
-          <p:cNvPr id="88" name="Rectangle 87"/>
+          <p:cNvPr id="91" name="Rectangle 90"/>
           <p:cNvSpPr/>
           <p:nvPr/>
         </p:nvSpPr>
@@ -6553,7 +6685,7 @@
       </p:sp>
       <p:sp>
         <p:nvSpPr>
-          <p:cNvPr id="89" name="Rectangle 88"/>
+          <p:cNvPr id="92" name="Rectangle 91"/>
           <p:cNvSpPr/>
           <p:nvPr/>
         </p:nvSpPr>
@@ -6597,7 +6729,7 @@
       </p:sp>
       <p:sp>
         <p:nvSpPr>
-          <p:cNvPr id="90" name="TextBox 89"/>
+          <p:cNvPr id="93" name="TextBox 92"/>
           <p:cNvSpPr txBox="1"/>
           <p:nvPr/>
         </p:nvSpPr>
@@ -6632,7 +6764,7 @@
       </p:sp>
       <p:sp>
         <p:nvSpPr>
-          <p:cNvPr id="91" name="Rectangle 90"/>
+          <p:cNvPr id="94" name="Rectangle 93"/>
           <p:cNvSpPr/>
           <p:nvPr/>
         </p:nvSpPr>
@@ -6676,7 +6808,7 @@
       </p:sp>
       <p:sp>
         <p:nvSpPr>
-          <p:cNvPr id="92" name="Rectangle 91"/>
+          <p:cNvPr id="95" name="Rectangle 94"/>
           <p:cNvSpPr/>
           <p:nvPr/>
         </p:nvSpPr>
@@ -6720,7 +6852,7 @@
       </p:sp>
       <p:sp>
         <p:nvSpPr>
-          <p:cNvPr id="93" name="Rectangle 92"/>
+          <p:cNvPr id="96" name="Rectangle 95"/>
           <p:cNvSpPr/>
           <p:nvPr/>
         </p:nvSpPr>
@@ -6764,7 +6896,7 @@
       </p:sp>
       <p:sp>
         <p:nvSpPr>
-          <p:cNvPr id="94" name="Rectangle 93"/>
+          <p:cNvPr id="97" name="Rectangle 96"/>
           <p:cNvSpPr/>
           <p:nvPr/>
         </p:nvSpPr>
@@ -6808,7 +6940,7 @@
       </p:sp>
       <p:sp>
         <p:nvSpPr>
-          <p:cNvPr id="95" name="Rectangle 94"/>
+          <p:cNvPr id="98" name="Rectangle 97"/>
           <p:cNvSpPr/>
           <p:nvPr/>
         </p:nvSpPr>

</xml_diff>